<commit_message>
Finalize practical online lab scripts and handoff for course sign-off
</commit_message>
<xml_diff>
--- a/산출물/교재/PPTX/실전반_온라인/실전반_06일차.pptx
+++ b/산출물/교재/PPTX/실전반_온라인/실전반_06일차.pptx
@@ -5271,7 +5271,7 @@
           <a:lstStyle/>
           <a:p>
             <a:r>
-              <a:t>작업 부품과 분기 조건을 빠뜨린 별도 초안에서 검사 사유를 읽고 원래 연결로 고치겠습니다. 정상 초안을 다시 검사해 판본으로 등록하고 배포합니다. 등록과 배포는 서로 다른 단계이며, 실행 결과는 다음 실습에서 확인합니다. 공용 환경에서는 마지막 배포가 경보 경로를 바꾸므로 내 환경과 현재 배포 대상을 먼저 확인하겠습니다.</a:t>
+              <a:t>앞 실습에서 작성한 초안을 검사하고 실제 문제의 위치와 사유를 읽겠습니다. 부품과 분기 조건 등에서 잘못된 항목이 있으면 고치고 다시 검사해 판본으로 등록하고 배포합니다. 문제가 없으면 검사 범위를 남기고 정상 설정을 비우지 않습니다. 등록과 배포는 서로 다른 단계이며, 실행 결과는 다음 실습에서 확인합니다. 공용 환경에서는 마지막 배포가 경보 경로를 바꾸므로 내 환경과 현재 배포 대상을 먼저 확인하겠습니다.</a:t>
             </a:r>
           </a:p>
         </p:txBody>
@@ -5551,7 +5551,7 @@
           <a:lstStyle/>
           <a:p>
             <a:r>
-              <a:t>실습에 이어 이번 회차를 정리하겠습니다. 처리 건에서 승인 대기와 끝난 상태를 구별해 보셨죠. 아직 기대한 결과를 얻지 못했다면, 어디까지 확인했고 무엇이 남았는지도 함께 적어 두세요. 그 눈으로 쿨러 사건 한 건을, 이번 회차에 배운 말로 다시 읽어 보겠습니다. 표 왼쪽의 장면마다 프로세스의 어떤 개념인지 먼저 말해 보세요. 그리고 오른쪽 열의 짝이 왜 서로 다른지 판단해 보세요. 첫 줄, 경보가 도착해서 처리 건이 열린 건, 메시지 시작 이벤트가 정의 하나에서 인스턴스 하나를 만든 거예요. 둘째 줄, 추천안이 나왔지만 팬은 그대로인 장면이죠. Task 하나가 끝난 순간입니다. End-to-End는 아직 진행 중이고요. 셋째 줄, 운전원 승인에서 기다리는 건 토큰이 사용자 작업에 머문 정상 상태입니다. 오류가 아니에요. 넷째 줄, 승인 여부 게이트웨이에서 승인 쪽으로 간 건 에이전트가 판단해서가 아닙니다. 운전원 승인이 낸 변수를 읽는 조건이 정한 거죠. 다섯째 줄, 운전원이 기한 안에 승인한 장면이에요. 승인 작업이 끝나면서 테두리의 비중단형 타이머도 함께 거둬졌습니다. 승인이 늦었다면 알림 가지만 열리고, 승인 작업은 그대로 기다렸겠죠. 알림이 나가는 것과 처리 건이 끝나는 것은 다른 일입니다. 마지막 줄, 쿨러 사건이 정상 보고로 끝난 건 끝 이벤트에 닿은 COMPLETED입니다. 그런데 거절로 닫힌 처리 건도 COMPLETED였죠. 성공인지 아닌지는 끝 이벤트와 결과 보고로 판단합니다. 여섯 장면이 전부 같은 그림, 같은 정의 위에서 일어났어요. 그림의 도형 하나하나가 실행에서 어떤 상태와 기록이 되는지 연결할 수 있으면, 처음 보는 처리 건도 읽어 낼 수 있습니다.</a:t>
+              <a:t>실습에 이어 이번 회차를 정리하겠습니다. 실습에서 남긴 기록으로 승인 대기와 끝난 상태를 구별하겠습니다. 아직 기대한 결과를 얻지 못했다면, 어디까지 확인했고 무엇이 남았는지도 함께 적어 두겠습니다. 그 눈으로 쿨러 사건 한 건을, 이번 회차에 배운 말로 다시 읽어 보겠습니다. 표 왼쪽의 장면마다 프로세스의 어떤 개념인지 먼저 말해 보세요. 그리고 오른쪽 열의 짝이 왜 서로 다른지 판단해 보세요. 첫 줄, 경보가 도착해서 처리 건이 열린 건, 메시지 시작 이벤트가 정의 하나에서 인스턴스 하나를 만든 거예요. 둘째 줄, 추천안이 나왔지만 팬은 그대로인 장면이죠. Task 하나가 끝난 순간입니다. End-to-End는 아직 진행 중이고요. 셋째 줄, 운전원 승인에서 기다리는 건 토큰이 사용자 작업에 머문 정상 상태입니다. 오류가 아니에요. 넷째 줄, 승인 여부 게이트웨이에서 승인 쪽으로 간 건 에이전트가 판단해서가 아닙니다. 운전원 승인이 낸 변수를 읽는 조건이 정한 거죠. 다섯째 줄, 운전원이 기한 안에 승인한 장면이에요. 승인 작업이 끝나면서 테두리의 비중단형 타이머도 함께 거둬졌습니다. 승인이 늦었다면 알림 가지만 열리고, 승인 작업은 그대로 기다렸겠죠. 알림이 나가는 것과 처리 건이 끝나는 것은 다른 일입니다. 마지막 줄, 쿨러 사건이 정상 보고로 끝난 건 끝 이벤트에 닿은 COMPLETED입니다. 그런데 거절로 닫힌 처리 건도 COMPLETED였죠. 성공인지 아닌지는 끝 이벤트와 결과 보고로 판단합니다. 여섯 장면이 전부 같은 그림, 같은 정의 위에서 일어났어요. 그림의 도형 하나하나가 실행에서 어떤 상태와 기록이 되는지 연결할 수 있으면, 처음 보는 처리 건도 읽어 낼 수 있습니다.</a:t>
             </a:r>
           </a:p>
         </p:txBody>
@@ -37652,7 +37652,7 @@
                 <a:ea typeface="맑은 고딕"/>
                 <a:cs typeface="맑은 고딕"/>
               </a:rPr>
-              <a:t>HYD에서는 경보로 열린 처리 건을 이 엔진이 정의의 조건에 따라 진행을 관리한다.</a:t>
+              <a:t>HYD에서는 이 엔진이 정의의 조건에 따라 경보로 열린 처리 건의 진행을 관리한다.</a:t>
             </a:r>
           </a:p>
         </p:txBody>

</xml_diff>